<commit_message>
Apply local changes; ignore large post_despacho CSV (remove from history)
</commit_message>
<xml_diff>
--- a/docs/Presentation.pptx
+++ b/docs/Presentation.pptx
@@ -8,6 +8,8 @@
     <p:sldId id="256" r:id="rId2"/>
     <p:sldId id="258" r:id="rId3"/>
     <p:sldId id="257" r:id="rId4"/>
+    <p:sldId id="260" r:id="rId5"/>
+    <p:sldId id="259" r:id="rId6"/>
   </p:sldIdLst>
   <p:sldSz cx="12192000" cy="6858000"/>
   <p:notesSz cx="6858000" cy="9144000"/>
@@ -114,6 +116,35 @@
 </p:presentation>
 </file>
 
+<file path=ppt/changesInfos/changesInfo1.xml><?xml version="1.0" encoding="utf-8"?>
+<pc:chgInfo xmlns:a="http://schemas.openxmlformats.org/drawingml/2006/main" xmlns:r="http://schemas.openxmlformats.org/officeDocument/2006/relationships" xmlns:ac="http://schemas.microsoft.com/office/drawing/2013/main/command" xmlns:pc="http://schemas.microsoft.com/office/powerpoint/2013/main/command">
+  <pc:docChgLst>
+    <pc:chgData name="Cornielle Candelario, Fernando Carlos" userId="314dfbf2-937d-4ccb-a525-2dfc418016b2" providerId="ADAL" clId="{A808AE9D-51C6-4633-A94F-FF47FA3A3528}"/>
+    <pc:docChg chg="addSld modSld">
+      <pc:chgData name="Cornielle Candelario, Fernando Carlos" userId="314dfbf2-937d-4ccb-a525-2dfc418016b2" providerId="ADAL" clId="{A808AE9D-51C6-4633-A94F-FF47FA3A3528}" dt="2025-06-13T17:12:19.606" v="3" actId="1076"/>
+      <pc:docMkLst>
+        <pc:docMk/>
+      </pc:docMkLst>
+      <pc:sldChg chg="addSp modSp new mod">
+        <pc:chgData name="Cornielle Candelario, Fernando Carlos" userId="314dfbf2-937d-4ccb-a525-2dfc418016b2" providerId="ADAL" clId="{A808AE9D-51C6-4633-A94F-FF47FA3A3528}" dt="2025-06-13T17:12:19.606" v="3" actId="1076"/>
+        <pc:sldMkLst>
+          <pc:docMk/>
+          <pc:sldMk cId="1946929122" sldId="259"/>
+        </pc:sldMkLst>
+        <pc:picChg chg="add mod">
+          <ac:chgData name="Cornielle Candelario, Fernando Carlos" userId="314dfbf2-937d-4ccb-a525-2dfc418016b2" providerId="ADAL" clId="{A808AE9D-51C6-4633-A94F-FF47FA3A3528}" dt="2025-06-13T17:12:19.606" v="3" actId="1076"/>
+          <ac:picMkLst>
+            <pc:docMk/>
+            <pc:sldMk cId="1946929122" sldId="259"/>
+            <ac:picMk id="3" creationId="{EFFCDE3D-0DC3-9B55-13FD-54AF72E5C2EB}"/>
+          </ac:picMkLst>
+        </pc:picChg>
+      </pc:sldChg>
+    </pc:docChg>
+  </pc:docChgLst>
+</pc:chgInfo>
+</file>
+
 <file path=ppt/slideLayouts/slideLayout1.xml><?xml version="1.0" encoding="utf-8"?>
 <p:sldLayout xmlns:a="http://schemas.openxmlformats.org/drawingml/2006/main" xmlns:r="http://schemas.openxmlformats.org/officeDocument/2006/relationships" xmlns:p="http://schemas.openxmlformats.org/presentationml/2006/main" type="title" preserve="1">
   <p:cSld name="Title Slide">
@@ -261,7 +292,7 @@
           <a:p>
             <a:fld id="{55C4C4B0-CEA8-4053-9574-5C6BCC735844}" type="datetimeFigureOut">
               <a:rPr lang="en-US" smtClean="0"/>
-              <a:t>5/8/2025</a:t>
+              <a:t>6/17/2025</a:t>
             </a:fld>
             <a:endParaRPr lang="en-US"/>
           </a:p>
@@ -459,7 +490,7 @@
           <a:p>
             <a:fld id="{55C4C4B0-CEA8-4053-9574-5C6BCC735844}" type="datetimeFigureOut">
               <a:rPr lang="en-US" smtClean="0"/>
-              <a:t>5/8/2025</a:t>
+              <a:t>6/17/2025</a:t>
             </a:fld>
             <a:endParaRPr lang="en-US"/>
           </a:p>
@@ -667,7 +698,7 @@
           <a:p>
             <a:fld id="{55C4C4B0-CEA8-4053-9574-5C6BCC735844}" type="datetimeFigureOut">
               <a:rPr lang="en-US" smtClean="0"/>
-              <a:t>5/8/2025</a:t>
+              <a:t>6/17/2025</a:t>
             </a:fld>
             <a:endParaRPr lang="en-US"/>
           </a:p>
@@ -865,7 +896,7 @@
           <a:p>
             <a:fld id="{55C4C4B0-CEA8-4053-9574-5C6BCC735844}" type="datetimeFigureOut">
               <a:rPr lang="en-US" smtClean="0"/>
-              <a:t>5/8/2025</a:t>
+              <a:t>6/17/2025</a:t>
             </a:fld>
             <a:endParaRPr lang="en-US"/>
           </a:p>
@@ -1140,7 +1171,7 @@
           <a:p>
             <a:fld id="{55C4C4B0-CEA8-4053-9574-5C6BCC735844}" type="datetimeFigureOut">
               <a:rPr lang="en-US" smtClean="0"/>
-              <a:t>5/8/2025</a:t>
+              <a:t>6/17/2025</a:t>
             </a:fld>
             <a:endParaRPr lang="en-US"/>
           </a:p>
@@ -1405,7 +1436,7 @@
           <a:p>
             <a:fld id="{55C4C4B0-CEA8-4053-9574-5C6BCC735844}" type="datetimeFigureOut">
               <a:rPr lang="en-US" smtClean="0"/>
-              <a:t>5/8/2025</a:t>
+              <a:t>6/17/2025</a:t>
             </a:fld>
             <a:endParaRPr lang="en-US"/>
           </a:p>
@@ -1817,7 +1848,7 @@
           <a:p>
             <a:fld id="{55C4C4B0-CEA8-4053-9574-5C6BCC735844}" type="datetimeFigureOut">
               <a:rPr lang="en-US" smtClean="0"/>
-              <a:t>5/8/2025</a:t>
+              <a:t>6/17/2025</a:t>
             </a:fld>
             <a:endParaRPr lang="en-US"/>
           </a:p>
@@ -1958,7 +1989,7 @@
           <a:p>
             <a:fld id="{55C4C4B0-CEA8-4053-9574-5C6BCC735844}" type="datetimeFigureOut">
               <a:rPr lang="en-US" smtClean="0"/>
-              <a:t>5/8/2025</a:t>
+              <a:t>6/17/2025</a:t>
             </a:fld>
             <a:endParaRPr lang="en-US"/>
           </a:p>
@@ -2071,7 +2102,7 @@
           <a:p>
             <a:fld id="{55C4C4B0-CEA8-4053-9574-5C6BCC735844}" type="datetimeFigureOut">
               <a:rPr lang="en-US" smtClean="0"/>
-              <a:t>5/8/2025</a:t>
+              <a:t>6/17/2025</a:t>
             </a:fld>
             <a:endParaRPr lang="en-US"/>
           </a:p>
@@ -2382,7 +2413,7 @@
           <a:p>
             <a:fld id="{55C4C4B0-CEA8-4053-9574-5C6BCC735844}" type="datetimeFigureOut">
               <a:rPr lang="en-US" smtClean="0"/>
-              <a:t>5/8/2025</a:t>
+              <a:t>6/17/2025</a:t>
             </a:fld>
             <a:endParaRPr lang="en-US"/>
           </a:p>
@@ -2670,7 +2701,7 @@
           <a:p>
             <a:fld id="{55C4C4B0-CEA8-4053-9574-5C6BCC735844}" type="datetimeFigureOut">
               <a:rPr lang="en-US" smtClean="0"/>
-              <a:t>5/8/2025</a:t>
+              <a:t>6/17/2025</a:t>
             </a:fld>
             <a:endParaRPr lang="en-US"/>
           </a:p>
@@ -2911,7 +2942,7 @@
           <a:p>
             <a:fld id="{55C4C4B0-CEA8-4053-9574-5C6BCC735844}" type="datetimeFigureOut">
               <a:rPr lang="en-US" smtClean="0"/>
-              <a:t>5/8/2025</a:t>
+              <a:t>6/17/2025</a:t>
             </a:fld>
             <a:endParaRPr lang="en-US"/>
           </a:p>
@@ -4381,6 +4412,163 @@
     <p:extLst>
       <p:ext uri="{BB962C8B-B14F-4D97-AF65-F5344CB8AC3E}">
         <p14:creationId xmlns:p14="http://schemas.microsoft.com/office/powerpoint/2010/main" val="1358350099"/>
+      </p:ext>
+    </p:extLst>
+  </p:cSld>
+  <p:clrMapOvr>
+    <a:masterClrMapping/>
+  </p:clrMapOvr>
+</p:sld>
+</file>
+
+<file path=ppt/slides/slide4.xml><?xml version="1.0" encoding="utf-8"?>
+<p:sld xmlns:a="http://schemas.openxmlformats.org/drawingml/2006/main" xmlns:r="http://schemas.openxmlformats.org/officeDocument/2006/relationships" xmlns:p="http://schemas.openxmlformats.org/presentationml/2006/main">
+  <p:cSld>
+    <p:spTree>
+      <p:nvGrpSpPr>
+        <p:cNvPr id="1" name=""/>
+        <p:cNvGrpSpPr/>
+        <p:nvPr/>
+      </p:nvGrpSpPr>
+      <p:grpSpPr>
+        <a:xfrm>
+          <a:off x="0" y="0"/>
+          <a:ext cx="0" cy="0"/>
+          <a:chOff x="0" y="0"/>
+          <a:chExt cx="0" cy="0"/>
+        </a:xfrm>
+      </p:grpSpPr>
+      <p:sp>
+        <p:nvSpPr>
+          <p:cNvPr id="3" name="TextBox 2">
+            <a:extLst>
+              <a:ext uri="{FF2B5EF4-FFF2-40B4-BE49-F238E27FC236}">
+                <a16:creationId xmlns:a16="http://schemas.microsoft.com/office/drawing/2014/main" id="{069FE59D-EBAF-453B-A448-20949C931C40}"/>
+              </a:ext>
+            </a:extLst>
+          </p:cNvPr>
+          <p:cNvSpPr txBox="1"/>
+          <p:nvPr/>
+        </p:nvSpPr>
+        <p:spPr>
+          <a:xfrm>
+            <a:off x="3047586" y="2274838"/>
+            <a:ext cx="6095170" cy="2308324"/>
+          </a:xfrm>
+          <a:prstGeom prst="rect">
+            <a:avLst/>
+          </a:prstGeom>
+          <a:noFill/>
+        </p:spPr>
+        <p:txBody>
+          <a:bodyPr wrap="square">
+            <a:spAutoFit/>
+          </a:bodyPr>
+          <a:lstStyle/>
+          <a:p>
+            <a:r>
+              <a:rPr lang="en-US" dirty="0"/>
+              <a:t>Since the location (18.2158, -71.0998) is in the Caribbean, Open-</a:t>
+            </a:r>
+            <a:r>
+              <a:rPr lang="en-US" dirty="0" err="1"/>
+              <a:t>Meteo</a:t>
+            </a:r>
+            <a:r>
+              <a:rPr lang="en-US" dirty="0"/>
+              <a:t> typically uses global models like </a:t>
+            </a:r>
+            <a:r>
+              <a:rPr lang="en-US" b="1" dirty="0"/>
+              <a:t>GFS</a:t>
+            </a:r>
+            <a:r>
+              <a:rPr lang="en-US" dirty="0"/>
+              <a:t> (Global Forecast System) from NOAA, or sometimes </a:t>
+            </a:r>
+            <a:r>
+              <a:rPr lang="en-US" b="1" dirty="0"/>
+              <a:t>ICON</a:t>
+            </a:r>
+            <a:r>
+              <a:rPr lang="en-US" dirty="0"/>
+              <a:t> (Icosahedral Nonhydrostatic Model) from the DWD, for their "</a:t>
+            </a:r>
+            <a:r>
+              <a:rPr lang="en-US" dirty="0" err="1"/>
+              <a:t>best_match</a:t>
+            </a:r>
+            <a:r>
+              <a:rPr lang="en-US" dirty="0"/>
+              <a:t>" forecasts in regions not covered by very high-resolution local models. Given the global nature and forecast length (up to 16 days), GFS is a very strong candidate.</a:t>
+            </a:r>
+          </a:p>
+        </p:txBody>
+      </p:sp>
+    </p:spTree>
+    <p:extLst>
+      <p:ext uri="{BB962C8B-B14F-4D97-AF65-F5344CB8AC3E}">
+        <p14:creationId xmlns:p14="http://schemas.microsoft.com/office/powerpoint/2010/main" val="2962535340"/>
+      </p:ext>
+    </p:extLst>
+  </p:cSld>
+  <p:clrMapOvr>
+    <a:masterClrMapping/>
+  </p:clrMapOvr>
+</p:sld>
+</file>
+
+<file path=ppt/slides/slide5.xml><?xml version="1.0" encoding="utf-8"?>
+<p:sld xmlns:a="http://schemas.openxmlformats.org/drawingml/2006/main" xmlns:r="http://schemas.openxmlformats.org/officeDocument/2006/relationships" xmlns:p="http://schemas.openxmlformats.org/presentationml/2006/main">
+  <p:cSld>
+    <p:spTree>
+      <p:nvGrpSpPr>
+        <p:cNvPr id="1" name=""/>
+        <p:cNvGrpSpPr/>
+        <p:nvPr/>
+      </p:nvGrpSpPr>
+      <p:grpSpPr>
+        <a:xfrm>
+          <a:off x="0" y="0"/>
+          <a:ext cx="0" cy="0"/>
+          <a:chOff x="0" y="0"/>
+          <a:chExt cx="0" cy="0"/>
+        </a:xfrm>
+      </p:grpSpPr>
+      <p:pic>
+        <p:nvPicPr>
+          <p:cNvPr id="3" name="Picture 2">
+            <a:extLst>
+              <a:ext uri="{FF2B5EF4-FFF2-40B4-BE49-F238E27FC236}">
+                <a16:creationId xmlns:a16="http://schemas.microsoft.com/office/drawing/2014/main" id="{EFFCDE3D-0DC3-9B55-13FD-54AF72E5C2EB}"/>
+              </a:ext>
+            </a:extLst>
+          </p:cNvPr>
+          <p:cNvPicPr>
+            <a:picLocks noChangeAspect="1"/>
+          </p:cNvPicPr>
+          <p:nvPr/>
+        </p:nvPicPr>
+        <p:blipFill>
+          <a:blip r:embed="rId2"/>
+          <a:stretch>
+            <a:fillRect/>
+          </a:stretch>
+        </p:blipFill>
+        <p:spPr>
+          <a:xfrm>
+            <a:off x="1913965" y="745435"/>
+            <a:ext cx="7867782" cy="4681330"/>
+          </a:xfrm>
+          <a:prstGeom prst="rect">
+            <a:avLst/>
+          </a:prstGeom>
+        </p:spPr>
+      </p:pic>
+    </p:spTree>
+    <p:extLst>
+      <p:ext uri="{BB962C8B-B14F-4D97-AF65-F5344CB8AC3E}">
+        <p14:creationId xmlns:p14="http://schemas.microsoft.com/office/powerpoint/2010/main" val="1946929122"/>
       </p:ext>
     </p:extLst>
   </p:cSld>

</xml_diff>